<commit_message>
fix(deck): describe every image instead of shipping its file path
PptxGenJS writes the image's absolute path into the slide's descr
attribute when altText is missing. That put a local path into a file
meant to be public, and it is exactly what a screen reader reads out, on
a deck whose subject is accessibility. build.js now refuses to place an
image without a description.
</commit_message>
<xml_diff>
--- a/deck/Reporting-Builder.pptx
+++ b/deck/Reporting-Builder.pptx
@@ -2073,7 +2073,7 @@
       </p:sp>
       <p:pic>
         <p:nvPicPr>
-          <p:cNvPr id="4" name="Image 0" descr="/Users/tonygpt/Desktop/PROJECTS/project-reporting-builder/deck/assets/app-icon.png">    </p:cNvPr>
+          <p:cNvPr id="4" name="app-icon.png" descr="The app icon: a blue document card on a white rounded plate.">    </p:cNvPr>
           <p:cNvPicPr>
             <a:picLocks noChangeAspect="1"/>
           </p:cNvPicPr>
@@ -4559,7 +4559,7 @@
       </p:sp>
       <p:pic>
         <p:nvPicPr>
-          <p:cNvPr id="22" name="Image 0" descr="/Users/tonygpt/Desktop/PROJECTS/project-reporting-builder/deck/assets/gallery-fade.png">    </p:cNvPr>
+          <p:cNvPr id="22" name="gallery-fade.png" descr="The published card gallery page, showing the weekly status and milestone templates rendered by the same HTML renderer the app uses for email.">    </p:cNvPr>
           <p:cNvPicPr>
             <a:picLocks noChangeAspect="1"/>
           </p:cNvPicPr>
@@ -6639,7 +6639,7 @@
       </p:sp>
       <p:pic>
         <p:nvPicPr>
-          <p:cNvPr id="7" name="Image 0" descr="/Users/tonygpt/Desktop/PROJECTS/project-reporting-builder/deck/assets/hero.png">    </p:cNvPr>
+          <p:cNvPr id="7" name="hero.png" descr="The app window: a list of cards on the left, a weekly status card being edited in the middle, and the Format inspector on the right showing themes, text size, status and width.">    </p:cNvPr>
           <p:cNvPicPr>
             <a:picLocks noChangeAspect="1"/>
           </p:cNvPicPr>
@@ -7663,7 +7663,7 @@
       </p:sp>
       <p:pic>
         <p:nvPicPr>
-          <p:cNvPr id="24" name="Image 0" descr="/Users/tonygpt/Desktop/PROJECTS/project-reporting-builder/deck/assets/missing.png">    </p:cNvPr>
+          <p:cNvPr id="24" name="missing.png" descr="The same card after a chart is dropped in: the toolbar shield is red, the image carries an Add Description button, and the Accessibility tab reports one error.">    </p:cNvPr>
           <p:cNvPicPr>
             <a:picLocks noChangeAspect="1"/>
           </p:cNvPicPr>
@@ -8979,7 +8979,7 @@
       </p:sp>
       <p:pic>
         <p:nvPicPr>
-          <p:cNvPr id="7" name="Image 0" descr="/Users/tonygpt/Desktop/PROJECTS/project-reporting-builder/deck/assets/before.png">    </p:cNvPr>
+          <p:cNvPr id="7" name="before.png" descr="The first interface: a form of fields on the left and a live preview on the right, with capital-letter labels and boxed tiles.">    </p:cNvPr>
           <p:cNvPicPr>
             <a:picLocks noChangeAspect="1"/>
           </p:cNvPicPr>
@@ -9075,7 +9075,7 @@
       </p:sp>
       <p:pic>
         <p:nvPicPr>
-          <p:cNvPr id="10" name="Image 1" descr="/Users/tonygpt/Desktop/PROJECTS/project-reporting-builder/deck/assets/hero.png">    </p:cNvPr>
+          <p:cNvPr id="10" name="hero.png" descr="The second interface: the card itself edited on a canvas, with its properties moved into a Format inspector.">    </p:cNvPr>
           <p:cNvPicPr>
             <a:picLocks noChangeAspect="1"/>
           </p:cNvPicPr>
@@ -9405,7 +9405,7 @@
       </p:sp>
       <p:pic>
         <p:nvPicPr>
-          <p:cNvPr id="7" name="Image 0" descr="/Users/tonygpt/Desktop/PROJECTS/project-reporting-builder/deck/assets/listen-crop.png">    </p:cNvPr>
+          <p:cNvPr id="7" name="listen-crop.png" descr="The spoken transcript: each line as a screen reader would say it, the line being read marked with a speaker glyph, and “Image. No description.” in red.">    </p:cNvPr>
           <p:cNvPicPr>
             <a:picLocks noChangeAspect="1"/>
           </p:cNvPicPr>
@@ -9540,7 +9540,7 @@
       </p:sp>
       <p:pic>
         <p:nvPicPr>
-          <p:cNvPr id="11" name="Image 1" descr="/Users/tonygpt/Desktop/PROJECTS/project-reporting-builder/deck/assets/cvd-crop.png">    </p:cNvPr>
+          <p:cNvPr id="11" name="cvd-crop.png" descr="The card simulated as seen with deuteranopia: the green and red of the status and the change arrows are gone, but the arrows, the words and the numbers still carry the meaning.">    </p:cNvPr>
           <p:cNvPicPr>
             <a:picLocks noChangeAspect="1"/>
           </p:cNvPicPr>
@@ -9675,7 +9675,7 @@
       </p:sp>
       <p:pic>
         <p:nvPicPr>
-          <p:cNvPr id="15" name="Image 2" descr="/Users/tonygpt/Desktop/PROJECTS/project-reporting-builder/deck/assets/checks-crop.png">    </p:cNvPr>
+          <p:cNvPr id="15" name="checks-crop.png" descr="The Accessibility tab reporting Needs Attention with one error, and the issue beneath it: describe this image for people who cannot see it, or mark it decorative, citing WCAG 1.1.1.">    </p:cNvPr>
           <p:cNvPicPr>
             <a:picLocks noChangeAspect="1"/>
           </p:cNvPicPr>
@@ -10872,7 +10872,7 @@
       </p:sp>
       <p:pic>
         <p:nvPicPr>
-          <p:cNvPr id="7" name="Image 0" descr="/Users/tonygpt/Desktop/PROJECTS/project-reporting-builder/deck/assets/draft.png">    </p:cNvPr>
+          <p:cNvPr id="7" name="draft.png" descr="New Card from Notes: rough meeting notes on the left, and on the right the drafted card with a title, status, summary, highlights, metrics, risks and next steps, above a line saying all fourteen accessibility checks passed.">    </p:cNvPr>
           <p:cNvPicPr>
             <a:picLocks noChangeAspect="1"/>
           </p:cNvPicPr>

</xml_diff>